<commit_message>
feat: Implement PKI for device authentication and content non-repudiation
- Add Certificate Authority (CA) functionality for issuing and verifying certificates.
- Introduce certificate format and payload structure for device identification.
- Implement key generation and signing mechanisms using ECDSA with SHA-256.
- Create nonce store for challenge-response handshake to prevent replay attacks.
- Develop client-side components for verifying content authenticity and managing device certificates.
- Add device management page for importing certificates and bypassing authentication.
- Document the PKI security model, including issuance, handshake, and non-repudiation processes.
</commit_message>
<xml_diff>
--- a/apresentacao/DEFESA.pptx
+++ b/apresentacao/DEFESA.pptx
@@ -8951,7 +8951,7 @@
                 <a:ea typeface="Cambria" pitchFamily="34" charset="-122"/>
                 <a:cs typeface="Cambria" pitchFamily="34" charset="-120"/>
               </a:rPr>
-              <a:t>Comunicação Segura</a:t>
+              <a:t>Segurança por Certificados (PKI / CA)</a:t>
             </a:r>
             <a:endParaRPr lang="en-US" sz="3700" dirty="0"/>
           </a:p>
@@ -9073,7 +9073,7 @@
                 <a:ea typeface="Cambria" pitchFamily="34" charset="-122"/>
                 <a:cs typeface="Cambria" pitchFamily="34" charset="-120"/>
               </a:rPr>
-              <a:t>JWT + bcrypt</a:t>
+              <a:t>Certificados (CA)</a:t>
             </a:r>
             <a:endParaRPr lang="en-US" sz="1700" dirty="0"/>
           </a:p>
@@ -9112,7 +9112,7 @@
                 <a:ea typeface="Calibri" pitchFamily="34" charset="-122"/>
                 <a:cs typeface="Calibri" pitchFamily="34" charset="-120"/>
               </a:rPr>
-              <a:t>Login com hash salgado; token Bearer.</a:t>
+              <a:t>A CA emite; só dispositivos com certificado conectam.</a:t>
             </a:r>
             <a:endParaRPr lang="en-US" sz="1300" dirty="0"/>
           </a:p>
@@ -9234,7 +9234,7 @@
                 <a:ea typeface="Cambria" pitchFamily="34" charset="-122"/>
                 <a:cs typeface="Cambria" pitchFamily="34" charset="-120"/>
               </a:rPr>
-              <a:t>Papéis</a:t>
+              <a:t>Handshake (prova de posse)</a:t>
             </a:r>
             <a:endParaRPr lang="en-US" sz="1700" dirty="0"/>
           </a:p>
@@ -9273,7 +9273,7 @@
                 <a:ea typeface="Calibri" pitchFamily="34" charset="-122"/>
                 <a:cs typeface="Calibri" pitchFamily="34" charset="-120"/>
               </a:rPr>
-              <a:t>Admin · Editor · Leitor (por rota).</a:t>
+              <a:t>Assina um desafio com a chave privada — anti man-in-the-middle.</a:t>
             </a:r>
             <a:endParaRPr lang="en-US" sz="1300" dirty="0"/>
           </a:p>
@@ -9395,7 +9395,7 @@
                 <a:ea typeface="Cambria" pitchFamily="34" charset="-122"/>
                 <a:cs typeface="Cambria" pitchFamily="34" charset="-120"/>
               </a:rPr>
-              <a:t>Validação zod</a:t>
+              <a:t>Não-repúdio</a:t>
             </a:r>
             <a:endParaRPr lang="en-US" sz="1700" dirty="0"/>
           </a:p>
@@ -9434,7 +9434,7 @@
                 <a:ea typeface="Calibri" pitchFamily="34" charset="-122"/>
                 <a:cs typeface="Calibri" pitchFamily="34" charset="-120"/>
               </a:rPr>
-              <a:t>Corpo dos pedidos validado antes da BD.</a:t>
+              <a:t>Conteúdo assinado; autoria verificável e à prova de adulteração.</a:t>
             </a:r>
             <a:endParaRPr lang="en-US" sz="1300" dirty="0"/>
           </a:p>
@@ -9556,7 +9556,7 @@
                 <a:ea typeface="Cambria" pitchFamily="34" charset="-122"/>
                 <a:cs typeface="Cambria" pitchFamily="34" charset="-120"/>
               </a:rPr>
-              <a:t>Helmet + CORS</a:t>
+              <a:t>Separação de papéis</a:t>
             </a:r>
             <a:endParaRPr lang="en-US" sz="1700" dirty="0"/>
           </a:p>
@@ -9595,7 +9595,7 @@
                 <a:ea typeface="Calibri" pitchFamily="34" charset="-122"/>
                 <a:cs typeface="Calibri" pitchFamily="34" charset="-120"/>
               </a:rPr>
-              <a:t>Cabeçalhos de segurança e origens.</a:t>
+              <a:t>Admin só gere contas/certificados; o Editor faz o conteúdo.</a:t>
             </a:r>
             <a:endParaRPr lang="en-US" sz="1300" dirty="0"/>
           </a:p>
@@ -9717,7 +9717,7 @@
                 <a:ea typeface="Cambria" pitchFamily="34" charset="-122"/>
                 <a:cs typeface="Cambria" pitchFamily="34" charset="-120"/>
               </a:rPr>
-              <a:t>Rate-limit</a:t>
+              <a:t>Anti-pirataria</a:t>
             </a:r>
             <a:endParaRPr lang="en-US" sz="1700" dirty="0"/>
           </a:p>
@@ -9756,7 +9756,7 @@
                 <a:ea typeface="Calibri" pitchFamily="34" charset="-122"/>
                 <a:cs typeface="Calibri" pitchFamily="34" charset="-120"/>
               </a:rPr>
-              <a:t>Anti força-bruta no login/registo.</a:t>
+              <a:t>Máquina sem certificado não obtém sessão (PKI_ENFORCE).</a:t>
             </a:r>
             <a:endParaRPr lang="en-US" sz="1300" dirty="0"/>
           </a:p>
@@ -9878,7 +9878,7 @@
                 <a:ea typeface="Cambria" pitchFamily="34" charset="-122"/>
                 <a:cs typeface="Cambria" pitchFamily="34" charset="-120"/>
               </a:rPr>
-              <a:t>Logs de auditoria</a:t>
+              <a:t>Base de segurança</a:t>
             </a:r>
             <a:endParaRPr lang="en-US" sz="1700" dirty="0"/>
           </a:p>
@@ -9917,7 +9917,7 @@
                 <a:ea typeface="Calibri" pitchFamily="34" charset="-122"/>
                 <a:cs typeface="Calibri" pitchFamily="34" charset="-120"/>
               </a:rPr>
-              <a:t>Registo de ações sensíveis.</a:t>
+              <a:t>JWT + bcrypt · zod · Helmet/CORS · rate-limit · logs.</a:t>
             </a:r>
             <a:endParaRPr lang="en-US" sz="1300" dirty="0"/>
           </a:p>

</xml_diff>